<commit_message>
feat: integrate content generation, assignment evaluation, adaptive engine, gamification, and supporting modules
Combines all work developed together since the last push into one integrated
snapshot: content generation (flashcards/MCQ/study guide/assignment drafts),
assignment grading + rubric generation, adaptive engine, gamification/concept
games, question bank, exams, live quiz, mastery tracking, study modes,
practice hub, course scheduling, and outcomes (CLO/PLO) tracking - plus fixes
across auth, analytics, knowledge graph, uploads, and RAG discovered and
resolved while integrating everything.
</commit_message>
<xml_diff>
--- a/ConceptIntel_Pitchdeck.pptx
+++ b/ConceptIntel_Pitchdeck.pptx
@@ -139,25 +139,17 @@
 </p:presentation>
 </file>
 
-<file path=ppt/revisionInfo.xml><?xml version="1.0" encoding="utf-8"?>
-<p1510:revInfo xmlns:a="http://schemas.openxmlformats.org/drawingml/2006/main" xmlns:r="http://schemas.openxmlformats.org/officeDocument/2006/relationships" xmlns:p1510="http://schemas.microsoft.com/office/powerpoint/2015/10/main">
-  <p1510:revLst>
-    <p1510:client id="{581936C1-43B3-4CC3-8C2B-356BACE09E30}" v="8" dt="2026-07-26T17:39:40.215"/>
-  </p1510:revLst>
-</p1510:revInfo>
-</file>
-
 <file path=ppt/changesInfos/changesInfo1.xml><?xml version="1.0" encoding="utf-8"?>
 <pc:chgInfo xmlns:a="http://schemas.openxmlformats.org/drawingml/2006/main" xmlns:r="http://schemas.openxmlformats.org/officeDocument/2006/relationships" xmlns:ac="http://schemas.microsoft.com/office/drawing/2013/main/command" xmlns:pc="http://schemas.microsoft.com/office/powerpoint/2013/main/command">
   <pc:docChgLst>
     <pc:chgData name="231662_Mamoona ." userId="b7081f7e7da24230" providerId="LiveId" clId="{91F99260-498A-4FEC-A0A5-5F34A1DABEDB}"/>
     <pc:docChg chg="undo redo custSel addSld delSld modSld sldOrd">
-      <pc:chgData name="231662_Mamoona ." userId="b7081f7e7da24230" providerId="LiveId" clId="{91F99260-498A-4FEC-A0A5-5F34A1DABEDB}" dt="2026-07-26T18:33:17.206" v="472" actId="20577"/>
+      <pc:chgData name="231662_Mamoona ." userId="b7081f7e7da24230" providerId="LiveId" clId="{91F99260-498A-4FEC-A0A5-5F34A1DABEDB}" dt="2026-08-22T18:47:35.244" v="475" actId="21"/>
       <pc:docMkLst>
         <pc:docMk/>
       </pc:docMkLst>
       <pc:sldChg chg="addSp delSp modSp mod">
-        <pc:chgData name="231662_Mamoona ." userId="b7081f7e7da24230" providerId="LiveId" clId="{91F99260-498A-4FEC-A0A5-5F34A1DABEDB}" dt="2026-07-26T18:33:17.206" v="472" actId="20577"/>
+        <pc:chgData name="231662_Mamoona ." userId="b7081f7e7da24230" providerId="LiveId" clId="{91F99260-498A-4FEC-A0A5-5F34A1DABEDB}" dt="2026-08-22T18:47:35.244" v="475" actId="21"/>
         <pc:sldMkLst>
           <pc:docMk/>
           <pc:sldMk cId="0" sldId="256"/>
@@ -184,62 +176,6 @@
             <pc:docMk/>
             <pc:sldMk cId="0" sldId="256"/>
             <ac:spMk id="7" creationId="{00000000-0000-0000-0000-000000000000}"/>
-          </ac:spMkLst>
-        </pc:spChg>
-        <pc:spChg chg="del mod">
-          <ac:chgData name="231662_Mamoona ." userId="b7081f7e7da24230" providerId="LiveId" clId="{91F99260-498A-4FEC-A0A5-5F34A1DABEDB}" dt="2026-07-26T17:10:45.676" v="17" actId="478"/>
-          <ac:spMkLst>
-            <pc:docMk/>
-            <pc:sldMk cId="0" sldId="256"/>
-            <ac:spMk id="8" creationId="{00000000-0000-0000-0000-000000000000}"/>
-          </ac:spMkLst>
-        </pc:spChg>
-        <pc:spChg chg="del">
-          <ac:chgData name="231662_Mamoona ." userId="b7081f7e7da24230" providerId="LiveId" clId="{91F99260-498A-4FEC-A0A5-5F34A1DABEDB}" dt="2026-07-26T17:10:20.371" v="11" actId="478"/>
-          <ac:spMkLst>
-            <pc:docMk/>
-            <pc:sldMk cId="0" sldId="256"/>
-            <ac:spMk id="9" creationId="{00000000-0000-0000-0000-000000000000}"/>
-          </ac:spMkLst>
-        </pc:spChg>
-        <pc:spChg chg="del mod">
-          <ac:chgData name="231662_Mamoona ." userId="b7081f7e7da24230" providerId="LiveId" clId="{91F99260-498A-4FEC-A0A5-5F34A1DABEDB}" dt="2026-07-26T17:10:14.415" v="9" actId="478"/>
-          <ac:spMkLst>
-            <pc:docMk/>
-            <pc:sldMk cId="0" sldId="256"/>
-            <ac:spMk id="10" creationId="{00000000-0000-0000-0000-000000000000}"/>
-          </ac:spMkLst>
-        </pc:spChg>
-        <pc:spChg chg="del">
-          <ac:chgData name="231662_Mamoona ." userId="b7081f7e7da24230" providerId="LiveId" clId="{91F99260-498A-4FEC-A0A5-5F34A1DABEDB}" dt="2026-07-26T17:10:22.964" v="12" actId="478"/>
-          <ac:spMkLst>
-            <pc:docMk/>
-            <pc:sldMk cId="0" sldId="256"/>
-            <ac:spMk id="11" creationId="{00000000-0000-0000-0000-000000000000}"/>
-          </ac:spMkLst>
-        </pc:spChg>
-        <pc:spChg chg="del">
-          <ac:chgData name="231662_Mamoona ." userId="b7081f7e7da24230" providerId="LiveId" clId="{91F99260-498A-4FEC-A0A5-5F34A1DABEDB}" dt="2026-07-26T17:10:09.041" v="7" actId="478"/>
-          <ac:spMkLst>
-            <pc:docMk/>
-            <pc:sldMk cId="0" sldId="256"/>
-            <ac:spMk id="12" creationId="{00000000-0000-0000-0000-000000000000}"/>
-          </ac:spMkLst>
-        </pc:spChg>
-        <pc:spChg chg="del">
-          <ac:chgData name="231662_Mamoona ." userId="b7081f7e7da24230" providerId="LiveId" clId="{91F99260-498A-4FEC-A0A5-5F34A1DABEDB}" dt="2026-07-26T17:10:25.242" v="13" actId="478"/>
-          <ac:spMkLst>
-            <pc:docMk/>
-            <pc:sldMk cId="0" sldId="256"/>
-            <ac:spMk id="13" creationId="{00000000-0000-0000-0000-000000000000}"/>
-          </ac:spMkLst>
-        </pc:spChg>
-        <pc:spChg chg="del">
-          <ac:chgData name="231662_Mamoona ." userId="b7081f7e7da24230" providerId="LiveId" clId="{91F99260-498A-4FEC-A0A5-5F34A1DABEDB}" dt="2026-07-26T17:10:17.516" v="10" actId="478"/>
-          <ac:spMkLst>
-            <pc:docMk/>
-            <pc:sldMk cId="0" sldId="256"/>
-            <ac:spMk id="14" creationId="{00000000-0000-0000-0000-000000000000}"/>
           </ac:spMkLst>
         </pc:spChg>
         <pc:spChg chg="mod">
@@ -290,8 +226,8 @@
             <ac:spMk id="22" creationId="{E5ADE440-3D95-D54C-0540-330A56DE5298}"/>
           </ac:spMkLst>
         </pc:spChg>
-        <pc:picChg chg="mod">
-          <ac:chgData name="231662_Mamoona ." userId="b7081f7e7da24230" providerId="LiveId" clId="{91F99260-498A-4FEC-A0A5-5F34A1DABEDB}" dt="2026-07-26T17:12:43.957" v="117" actId="1076"/>
+        <pc:picChg chg="add del mod">
+          <ac:chgData name="231662_Mamoona ." userId="b7081f7e7da24230" providerId="LiveId" clId="{91F99260-498A-4FEC-A0A5-5F34A1DABEDB}" dt="2026-08-22T18:47:35.244" v="475" actId="21"/>
           <ac:picMkLst>
             <pc:docMk/>
             <pc:sldMk cId="0" sldId="256"/>
@@ -328,158 +264,6 @@
           <pc:docMk/>
           <pc:sldMk cId="0" sldId="258"/>
         </pc:sldMkLst>
-        <pc:spChg chg="del">
-          <ac:chgData name="231662_Mamoona ." userId="b7081f7e7da24230" providerId="LiveId" clId="{91F99260-498A-4FEC-A0A5-5F34A1DABEDB}" dt="2026-07-26T17:32:08.373" v="355" actId="478"/>
-          <ac:spMkLst>
-            <pc:docMk/>
-            <pc:sldMk cId="0" sldId="258"/>
-            <ac:spMk id="4" creationId="{00000000-0000-0000-0000-000000000000}"/>
-          </ac:spMkLst>
-        </pc:spChg>
-        <pc:spChg chg="del mod">
-          <ac:chgData name="231662_Mamoona ." userId="b7081f7e7da24230" providerId="LiveId" clId="{91F99260-498A-4FEC-A0A5-5F34A1DABEDB}" dt="2026-07-26T17:32:26.154" v="357" actId="478"/>
-          <ac:spMkLst>
-            <pc:docMk/>
-            <pc:sldMk cId="0" sldId="258"/>
-            <ac:spMk id="5" creationId="{00000000-0000-0000-0000-000000000000}"/>
-          </ac:spMkLst>
-        </pc:spChg>
-        <pc:spChg chg="del">
-          <ac:chgData name="231662_Mamoona ." userId="b7081f7e7da24230" providerId="LiveId" clId="{91F99260-498A-4FEC-A0A5-5F34A1DABEDB}" dt="2026-07-26T17:28:49.088" v="326" actId="478"/>
-          <ac:spMkLst>
-            <pc:docMk/>
-            <pc:sldMk cId="0" sldId="258"/>
-            <ac:spMk id="6" creationId="{00000000-0000-0000-0000-000000000000}"/>
-          </ac:spMkLst>
-        </pc:spChg>
-        <pc:spChg chg="del">
-          <ac:chgData name="231662_Mamoona ." userId="b7081f7e7da24230" providerId="LiveId" clId="{91F99260-498A-4FEC-A0A5-5F34A1DABEDB}" dt="2026-07-26T17:28:47.139" v="325" actId="478"/>
-          <ac:spMkLst>
-            <pc:docMk/>
-            <pc:sldMk cId="0" sldId="258"/>
-            <ac:spMk id="7" creationId="{00000000-0000-0000-0000-000000000000}"/>
-          </ac:spMkLst>
-        </pc:spChg>
-        <pc:spChg chg="del">
-          <ac:chgData name="231662_Mamoona ." userId="b7081f7e7da24230" providerId="LiveId" clId="{91F99260-498A-4FEC-A0A5-5F34A1DABEDB}" dt="2026-07-26T17:28:51.058" v="327" actId="478"/>
-          <ac:spMkLst>
-            <pc:docMk/>
-            <pc:sldMk cId="0" sldId="258"/>
-            <ac:spMk id="8" creationId="{00000000-0000-0000-0000-000000000000}"/>
-          </ac:spMkLst>
-        </pc:spChg>
-        <pc:spChg chg="del">
-          <ac:chgData name="231662_Mamoona ." userId="b7081f7e7da24230" providerId="LiveId" clId="{91F99260-498A-4FEC-A0A5-5F34A1DABEDB}" dt="2026-07-26T17:28:21.288" v="315" actId="478"/>
-          <ac:spMkLst>
-            <pc:docMk/>
-            <pc:sldMk cId="0" sldId="258"/>
-            <ac:spMk id="9" creationId="{00000000-0000-0000-0000-000000000000}"/>
-          </ac:spMkLst>
-        </pc:spChg>
-        <pc:spChg chg="del">
-          <ac:chgData name="231662_Mamoona ." userId="b7081f7e7da24230" providerId="LiveId" clId="{91F99260-498A-4FEC-A0A5-5F34A1DABEDB}" dt="2026-07-26T17:28:52.593" v="328" actId="478"/>
-          <ac:spMkLst>
-            <pc:docMk/>
-            <pc:sldMk cId="0" sldId="258"/>
-            <ac:spMk id="10" creationId="{00000000-0000-0000-0000-000000000000}"/>
-          </ac:spMkLst>
-        </pc:spChg>
-        <pc:spChg chg="del">
-          <ac:chgData name="231662_Mamoona ." userId="b7081f7e7da24230" providerId="LiveId" clId="{91F99260-498A-4FEC-A0A5-5F34A1DABEDB}" dt="2026-07-26T17:28:17.879" v="314" actId="478"/>
-          <ac:spMkLst>
-            <pc:docMk/>
-            <pc:sldMk cId="0" sldId="258"/>
-            <ac:spMk id="11" creationId="{00000000-0000-0000-0000-000000000000}"/>
-          </ac:spMkLst>
-        </pc:spChg>
-        <pc:spChg chg="del">
-          <ac:chgData name="231662_Mamoona ." userId="b7081f7e7da24230" providerId="LiveId" clId="{91F99260-498A-4FEC-A0A5-5F34A1DABEDB}" dt="2026-07-26T17:28:25.233" v="317" actId="478"/>
-          <ac:spMkLst>
-            <pc:docMk/>
-            <pc:sldMk cId="0" sldId="258"/>
-            <ac:spMk id="12" creationId="{00000000-0000-0000-0000-000000000000}"/>
-          </ac:spMkLst>
-        </pc:spChg>
-        <pc:spChg chg="del">
-          <ac:chgData name="231662_Mamoona ." userId="b7081f7e7da24230" providerId="LiveId" clId="{91F99260-498A-4FEC-A0A5-5F34A1DABEDB}" dt="2026-07-26T17:28:41.656" v="323" actId="478"/>
-          <ac:spMkLst>
-            <pc:docMk/>
-            <pc:sldMk cId="0" sldId="258"/>
-            <ac:spMk id="13" creationId="{00000000-0000-0000-0000-000000000000}"/>
-          </ac:spMkLst>
-        </pc:spChg>
-        <pc:spChg chg="del">
-          <ac:chgData name="231662_Mamoona ." userId="b7081f7e7da24230" providerId="LiveId" clId="{91F99260-498A-4FEC-A0A5-5F34A1DABEDB}" dt="2026-07-26T17:28:44.232" v="324" actId="478"/>
-          <ac:spMkLst>
-            <pc:docMk/>
-            <pc:sldMk cId="0" sldId="258"/>
-            <ac:spMk id="14" creationId="{00000000-0000-0000-0000-000000000000}"/>
-          </ac:spMkLst>
-        </pc:spChg>
-        <pc:spChg chg="del">
-          <ac:chgData name="231662_Mamoona ." userId="b7081f7e7da24230" providerId="LiveId" clId="{91F99260-498A-4FEC-A0A5-5F34A1DABEDB}" dt="2026-07-26T17:28:38.933" v="322" actId="478"/>
-          <ac:spMkLst>
-            <pc:docMk/>
-            <pc:sldMk cId="0" sldId="258"/>
-            <ac:spMk id="15" creationId="{00000000-0000-0000-0000-000000000000}"/>
-          </ac:spMkLst>
-        </pc:spChg>
-        <pc:spChg chg="del">
-          <ac:chgData name="231662_Mamoona ." userId="b7081f7e7da24230" providerId="LiveId" clId="{91F99260-498A-4FEC-A0A5-5F34A1DABEDB}" dt="2026-07-26T17:28:23.951" v="316" actId="478"/>
-          <ac:spMkLst>
-            <pc:docMk/>
-            <pc:sldMk cId="0" sldId="258"/>
-            <ac:spMk id="16" creationId="{00000000-0000-0000-0000-000000000000}"/>
-          </ac:spMkLst>
-        </pc:spChg>
-        <pc:spChg chg="del">
-          <ac:chgData name="231662_Mamoona ." userId="b7081f7e7da24230" providerId="LiveId" clId="{91F99260-498A-4FEC-A0A5-5F34A1DABEDB}" dt="2026-07-26T17:28:32.337" v="320" actId="478"/>
-          <ac:spMkLst>
-            <pc:docMk/>
-            <pc:sldMk cId="0" sldId="258"/>
-            <ac:spMk id="17" creationId="{00000000-0000-0000-0000-000000000000}"/>
-          </ac:spMkLst>
-        </pc:spChg>
-        <pc:spChg chg="del">
-          <ac:chgData name="231662_Mamoona ." userId="b7081f7e7da24230" providerId="LiveId" clId="{91F99260-498A-4FEC-A0A5-5F34A1DABEDB}" dt="2026-07-26T17:28:30.233" v="319" actId="478"/>
-          <ac:spMkLst>
-            <pc:docMk/>
-            <pc:sldMk cId="0" sldId="258"/>
-            <ac:spMk id="18" creationId="{00000000-0000-0000-0000-000000000000}"/>
-          </ac:spMkLst>
-        </pc:spChg>
-        <pc:spChg chg="del">
-          <ac:chgData name="231662_Mamoona ." userId="b7081f7e7da24230" providerId="LiveId" clId="{91F99260-498A-4FEC-A0A5-5F34A1DABEDB}" dt="2026-07-26T17:28:27.338" v="318" actId="478"/>
-          <ac:spMkLst>
-            <pc:docMk/>
-            <pc:sldMk cId="0" sldId="258"/>
-            <ac:spMk id="19" creationId="{00000000-0000-0000-0000-000000000000}"/>
-          </ac:spMkLst>
-        </pc:spChg>
-        <pc:spChg chg="del">
-          <ac:chgData name="231662_Mamoona ." userId="b7081f7e7da24230" providerId="LiveId" clId="{91F99260-498A-4FEC-A0A5-5F34A1DABEDB}" dt="2026-07-26T17:28:33.936" v="321" actId="478"/>
-          <ac:spMkLst>
-            <pc:docMk/>
-            <pc:sldMk cId="0" sldId="258"/>
-            <ac:spMk id="20" creationId="{00000000-0000-0000-0000-000000000000}"/>
-          </ac:spMkLst>
-        </pc:spChg>
-        <pc:spChg chg="add del mod">
-          <ac:chgData name="231662_Mamoona ." userId="b7081f7e7da24230" providerId="LiveId" clId="{91F99260-498A-4FEC-A0A5-5F34A1DABEDB}" dt="2026-07-26T17:31:14.668" v="350" actId="478"/>
-          <ac:spMkLst>
-            <pc:docMk/>
-            <pc:sldMk cId="0" sldId="258"/>
-            <ac:spMk id="24" creationId="{83AE4034-11D3-38C6-C4C5-DFFF29F04F7C}"/>
-          </ac:spMkLst>
-        </pc:spChg>
-        <pc:spChg chg="add mod">
-          <ac:chgData name="231662_Mamoona ." userId="b7081f7e7da24230" providerId="LiveId" clId="{91F99260-498A-4FEC-A0A5-5F34A1DABEDB}" dt="2026-07-26T17:29:20.568" v="335"/>
-          <ac:spMkLst>
-            <pc:docMk/>
-            <pc:sldMk cId="0" sldId="258"/>
-            <ac:spMk id="25" creationId="{CE0B7926-C2C1-382D-C088-6C23EED6611C}"/>
-          </ac:spMkLst>
-        </pc:spChg>
         <pc:spChg chg="add mod">
           <ac:chgData name="231662_Mamoona ." userId="b7081f7e7da24230" providerId="LiveId" clId="{91F99260-498A-4FEC-A0A5-5F34A1DABEDB}" dt="2026-07-26T17:33:00.754" v="361" actId="2711"/>
           <ac:spMkLst>
@@ -511,14 +295,6 @@
             <ac:spMk id="4" creationId="{00000000-0000-0000-0000-000000000000}"/>
           </ac:spMkLst>
         </pc:spChg>
-        <pc:graphicFrameChg chg="add del modGraphic">
-          <ac:chgData name="231662_Mamoona ." userId="b7081f7e7da24230" providerId="LiveId" clId="{91F99260-498A-4FEC-A0A5-5F34A1DABEDB}" dt="2026-07-26T17:22:50.556" v="286" actId="21"/>
-          <ac:graphicFrameMkLst>
-            <pc:docMk/>
-            <pc:sldMk cId="0" sldId="259"/>
-            <ac:graphicFrameMk id="106" creationId="{12116323-4958-613A-1867-F9179DBF59E2}"/>
-          </ac:graphicFrameMkLst>
-        </pc:graphicFrameChg>
       </pc:sldChg>
       <pc:sldChg chg="modSp mod">
         <pc:chgData name="231662_Mamoona ." userId="b7081f7e7da24230" providerId="LiveId" clId="{91F99260-498A-4FEC-A0A5-5F34A1DABEDB}" dt="2026-07-26T17:13:48.138" v="132" actId="20577"/>
@@ -572,38 +348,6 @@
             <ac:spMk id="3" creationId="{00000000-0000-0000-0000-000000000000}"/>
           </ac:spMkLst>
         </pc:spChg>
-        <pc:spChg chg="add del">
-          <ac:chgData name="231662_Mamoona ." userId="b7081f7e7da24230" providerId="LiveId" clId="{91F99260-498A-4FEC-A0A5-5F34A1DABEDB}" dt="2026-07-26T17:18:57.585" v="223" actId="22"/>
-          <ac:spMkLst>
-            <pc:docMk/>
-            <pc:sldMk cId="0" sldId="262"/>
-            <ac:spMk id="15" creationId="{9E37567D-02D1-EBED-FFC2-5C30A3B85F50}"/>
-          </ac:spMkLst>
-        </pc:spChg>
-        <pc:spChg chg="add del">
-          <ac:chgData name="231662_Mamoona ." userId="b7081f7e7da24230" providerId="LiveId" clId="{91F99260-498A-4FEC-A0A5-5F34A1DABEDB}" dt="2026-07-26T17:18:57.585" v="223" actId="22"/>
-          <ac:spMkLst>
-            <pc:docMk/>
-            <pc:sldMk cId="0" sldId="262"/>
-            <ac:spMk id="17" creationId="{D4D53F8A-A5AD-209A-3B32-2C1EA4A8D660}"/>
-          </ac:spMkLst>
-        </pc:spChg>
-        <pc:spChg chg="add del">
-          <ac:chgData name="231662_Mamoona ." userId="b7081f7e7da24230" providerId="LiveId" clId="{91F99260-498A-4FEC-A0A5-5F34A1DABEDB}" dt="2026-07-26T17:18:57.585" v="223" actId="22"/>
-          <ac:spMkLst>
-            <pc:docMk/>
-            <pc:sldMk cId="0" sldId="262"/>
-            <ac:spMk id="19" creationId="{B1FECCDC-5855-29CD-208B-E69F3EA23AE0}"/>
-          </ac:spMkLst>
-        </pc:spChg>
-        <pc:spChg chg="add del">
-          <ac:chgData name="231662_Mamoona ." userId="b7081f7e7da24230" providerId="LiveId" clId="{91F99260-498A-4FEC-A0A5-5F34A1DABEDB}" dt="2026-07-26T17:18:57.585" v="223" actId="22"/>
-          <ac:spMkLst>
-            <pc:docMk/>
-            <pc:sldMk cId="0" sldId="262"/>
-            <ac:spMk id="21" creationId="{3857BBA3-F044-7EA6-2384-26E183296A5C}"/>
-          </ac:spMkLst>
-        </pc:spChg>
       </pc:sldChg>
       <pc:sldChg chg="addSp delSp modSp mod">
         <pc:chgData name="231662_Mamoona ." userId="b7081f7e7da24230" providerId="LiveId" clId="{91F99260-498A-4FEC-A0A5-5F34A1DABEDB}" dt="2026-07-26T17:20:04.490" v="260" actId="22"/>
@@ -617,78 +361,6 @@
             <pc:docMk/>
             <pc:sldMk cId="0" sldId="263"/>
             <ac:spMk id="2" creationId="{00000000-0000-0000-0000-000000000000}"/>
-          </ac:spMkLst>
-        </pc:spChg>
-        <pc:spChg chg="del mod">
-          <ac:chgData name="231662_Mamoona ." userId="b7081f7e7da24230" providerId="LiveId" clId="{91F99260-498A-4FEC-A0A5-5F34A1DABEDB}" dt="2026-07-26T17:20:03.983" v="259" actId="478"/>
-          <ac:spMkLst>
-            <pc:docMk/>
-            <pc:sldMk cId="0" sldId="263"/>
-            <ac:spMk id="3" creationId="{00000000-0000-0000-0000-000000000000}"/>
-          </ac:spMkLst>
-        </pc:spChg>
-        <pc:spChg chg="del">
-          <ac:chgData name="231662_Mamoona ." userId="b7081f7e7da24230" providerId="LiveId" clId="{91F99260-498A-4FEC-A0A5-5F34A1DABEDB}" dt="2026-07-26T17:19:43.670" v="254" actId="478"/>
-          <ac:spMkLst>
-            <pc:docMk/>
-            <pc:sldMk cId="0" sldId="263"/>
-            <ac:spMk id="4" creationId="{00000000-0000-0000-0000-000000000000}"/>
-          </ac:spMkLst>
-        </pc:spChg>
-        <pc:spChg chg="del">
-          <ac:chgData name="231662_Mamoona ." userId="b7081f7e7da24230" providerId="LiveId" clId="{91F99260-498A-4FEC-A0A5-5F34A1DABEDB}" dt="2026-07-26T17:19:57.135" v="258" actId="478"/>
-          <ac:spMkLst>
-            <pc:docMk/>
-            <pc:sldMk cId="0" sldId="263"/>
-            <ac:spMk id="5" creationId="{00000000-0000-0000-0000-000000000000}"/>
-          </ac:spMkLst>
-        </pc:spChg>
-        <pc:spChg chg="del">
-          <ac:chgData name="231662_Mamoona ." userId="b7081f7e7da24230" providerId="LiveId" clId="{91F99260-498A-4FEC-A0A5-5F34A1DABEDB}" dt="2026-07-26T17:19:43.670" v="254" actId="478"/>
-          <ac:spMkLst>
-            <pc:docMk/>
-            <pc:sldMk cId="0" sldId="263"/>
-            <ac:spMk id="6" creationId="{00000000-0000-0000-0000-000000000000}"/>
-          </ac:spMkLst>
-        </pc:spChg>
-        <pc:spChg chg="del">
-          <ac:chgData name="231662_Mamoona ." userId="b7081f7e7da24230" providerId="LiveId" clId="{91F99260-498A-4FEC-A0A5-5F34A1DABEDB}" dt="2026-07-26T17:19:51.296" v="257" actId="478"/>
-          <ac:spMkLst>
-            <pc:docMk/>
-            <pc:sldMk cId="0" sldId="263"/>
-            <ac:spMk id="7" creationId="{00000000-0000-0000-0000-000000000000}"/>
-          </ac:spMkLst>
-        </pc:spChg>
-        <pc:spChg chg="del">
-          <ac:chgData name="231662_Mamoona ." userId="b7081f7e7da24230" providerId="LiveId" clId="{91F99260-498A-4FEC-A0A5-5F34A1DABEDB}" dt="2026-07-26T17:19:43.670" v="254" actId="478"/>
-          <ac:spMkLst>
-            <pc:docMk/>
-            <pc:sldMk cId="0" sldId="263"/>
-            <ac:spMk id="8" creationId="{00000000-0000-0000-0000-000000000000}"/>
-          </ac:spMkLst>
-        </pc:spChg>
-        <pc:spChg chg="del">
-          <ac:chgData name="231662_Mamoona ." userId="b7081f7e7da24230" providerId="LiveId" clId="{91F99260-498A-4FEC-A0A5-5F34A1DABEDB}" dt="2026-07-26T17:19:48.660" v="256" actId="478"/>
-          <ac:spMkLst>
-            <pc:docMk/>
-            <pc:sldMk cId="0" sldId="263"/>
-            <ac:spMk id="9" creationId="{00000000-0000-0000-0000-000000000000}"/>
-          </ac:spMkLst>
-        </pc:spChg>
-        <pc:spChg chg="del">
-          <ac:chgData name="231662_Mamoona ." userId="b7081f7e7da24230" providerId="LiveId" clId="{91F99260-498A-4FEC-A0A5-5F34A1DABEDB}" dt="2026-07-26T17:19:43.670" v="254" actId="478"/>
-          <ac:spMkLst>
-            <pc:docMk/>
-            <pc:sldMk cId="0" sldId="263"/>
-            <ac:spMk id="10" creationId="{00000000-0000-0000-0000-000000000000}"/>
-          </ac:spMkLst>
-        </pc:spChg>
-        <pc:spChg chg="del mod">
-          <ac:chgData name="231662_Mamoona ." userId="b7081f7e7da24230" providerId="LiveId" clId="{91F99260-498A-4FEC-A0A5-5F34A1DABEDB}" dt="2026-07-26T17:19:46.419" v="255" actId="478"/>
-          <ac:spMkLst>
-            <pc:docMk/>
-            <pc:sldMk cId="0" sldId="263"/>
-            <ac:spMk id="11" creationId="{00000000-0000-0000-0000-000000000000}"/>
           </ac:spMkLst>
         </pc:spChg>
         <pc:picChg chg="add">
@@ -736,86 +408,6 @@
           <pc:docMk/>
           <pc:sldMk cId="0" sldId="271"/>
         </pc:sldMkLst>
-        <pc:spChg chg="del">
-          <ac:chgData name="231662_Mamoona ." userId="b7081f7e7da24230" providerId="LiveId" clId="{91F99260-498A-4FEC-A0A5-5F34A1DABEDB}" dt="2026-07-26T17:36:33.869" v="383" actId="478"/>
-          <ac:spMkLst>
-            <pc:docMk/>
-            <pc:sldMk cId="0" sldId="271"/>
-            <ac:spMk id="4" creationId="{00000000-0000-0000-0000-000000000000}"/>
-          </ac:spMkLst>
-        </pc:spChg>
-        <pc:spChg chg="del">
-          <ac:chgData name="231662_Mamoona ." userId="b7081f7e7da24230" providerId="LiveId" clId="{91F99260-498A-4FEC-A0A5-5F34A1DABEDB}" dt="2026-07-26T17:36:29.015" v="381" actId="478"/>
-          <ac:spMkLst>
-            <pc:docMk/>
-            <pc:sldMk cId="0" sldId="271"/>
-            <ac:spMk id="7" creationId="{00000000-0000-0000-0000-000000000000}"/>
-          </ac:spMkLst>
-        </pc:spChg>
-        <pc:spChg chg="del">
-          <ac:chgData name="231662_Mamoona ." userId="b7081f7e7da24230" providerId="LiveId" clId="{91F99260-498A-4FEC-A0A5-5F34A1DABEDB}" dt="2026-07-26T17:36:29.015" v="381" actId="478"/>
-          <ac:spMkLst>
-            <pc:docMk/>
-            <pc:sldMk cId="0" sldId="271"/>
-            <ac:spMk id="8" creationId="{00000000-0000-0000-0000-000000000000}"/>
-          </ac:spMkLst>
-        </pc:spChg>
-        <pc:spChg chg="del">
-          <ac:chgData name="231662_Mamoona ." userId="b7081f7e7da24230" providerId="LiveId" clId="{91F99260-498A-4FEC-A0A5-5F34A1DABEDB}" dt="2026-07-26T17:36:29.015" v="381" actId="478"/>
-          <ac:spMkLst>
-            <pc:docMk/>
-            <pc:sldMk cId="0" sldId="271"/>
-            <ac:spMk id="9" creationId="{00000000-0000-0000-0000-000000000000}"/>
-          </ac:spMkLst>
-        </pc:spChg>
-        <pc:spChg chg="del mod">
-          <ac:chgData name="231662_Mamoona ." userId="b7081f7e7da24230" providerId="LiveId" clId="{91F99260-498A-4FEC-A0A5-5F34A1DABEDB}" dt="2026-07-26T17:36:38.777" v="385" actId="478"/>
-          <ac:spMkLst>
-            <pc:docMk/>
-            <pc:sldMk cId="0" sldId="271"/>
-            <ac:spMk id="11" creationId="{00000000-0000-0000-0000-000000000000}"/>
-          </ac:spMkLst>
-        </pc:spChg>
-        <pc:spChg chg="del">
-          <ac:chgData name="231662_Mamoona ." userId="b7081f7e7da24230" providerId="LiveId" clId="{91F99260-498A-4FEC-A0A5-5F34A1DABEDB}" dt="2026-07-26T17:36:40.059" v="386" actId="478"/>
-          <ac:spMkLst>
-            <pc:docMk/>
-            <pc:sldMk cId="0" sldId="271"/>
-            <ac:spMk id="12" creationId="{00000000-0000-0000-0000-000000000000}"/>
-          </ac:spMkLst>
-        </pc:spChg>
-        <pc:spChg chg="del">
-          <ac:chgData name="231662_Mamoona ." userId="b7081f7e7da24230" providerId="LiveId" clId="{91F99260-498A-4FEC-A0A5-5F34A1DABEDB}" dt="2026-07-26T17:36:29.015" v="381" actId="478"/>
-          <ac:spMkLst>
-            <pc:docMk/>
-            <pc:sldMk cId="0" sldId="271"/>
-            <ac:spMk id="13" creationId="{00000000-0000-0000-0000-000000000000}"/>
-          </ac:spMkLst>
-        </pc:spChg>
-        <pc:spChg chg="del">
-          <ac:chgData name="231662_Mamoona ." userId="b7081f7e7da24230" providerId="LiveId" clId="{91F99260-498A-4FEC-A0A5-5F34A1DABEDB}" dt="2026-07-26T17:36:29.015" v="381" actId="478"/>
-          <ac:spMkLst>
-            <pc:docMk/>
-            <pc:sldMk cId="0" sldId="271"/>
-            <ac:spMk id="14" creationId="{00000000-0000-0000-0000-000000000000}"/>
-          </ac:spMkLst>
-        </pc:spChg>
-        <pc:spChg chg="del">
-          <ac:chgData name="231662_Mamoona ." userId="b7081f7e7da24230" providerId="LiveId" clId="{91F99260-498A-4FEC-A0A5-5F34A1DABEDB}" dt="2026-07-26T17:36:29.015" v="381" actId="478"/>
-          <ac:spMkLst>
-            <pc:docMk/>
-            <pc:sldMk cId="0" sldId="271"/>
-            <ac:spMk id="15" creationId="{00000000-0000-0000-0000-000000000000}"/>
-          </ac:spMkLst>
-        </pc:spChg>
-        <pc:spChg chg="del">
-          <ac:chgData name="231662_Mamoona ." userId="b7081f7e7da24230" providerId="LiveId" clId="{91F99260-498A-4FEC-A0A5-5F34A1DABEDB}" dt="2026-07-26T17:36:29.015" v="381" actId="478"/>
-          <ac:spMkLst>
-            <pc:docMk/>
-            <pc:sldMk cId="0" sldId="271"/>
-            <ac:spMk id="18" creationId="{00000000-0000-0000-0000-000000000000}"/>
-          </ac:spMkLst>
-        </pc:spChg>
         <pc:spChg chg="mod">
           <ac:chgData name="231662_Mamoona ." userId="b7081f7e7da24230" providerId="LiveId" clId="{91F99260-498A-4FEC-A0A5-5F34A1DABEDB}" dt="2026-07-26T17:37:49.898" v="399" actId="14100"/>
           <ac:spMkLst>
@@ -824,94 +416,6 @@
             <ac:spMk id="19" creationId="{00000000-0000-0000-0000-000000000000}"/>
           </ac:spMkLst>
         </pc:spChg>
-        <pc:spChg chg="del">
-          <ac:chgData name="231662_Mamoona ." userId="b7081f7e7da24230" providerId="LiveId" clId="{91F99260-498A-4FEC-A0A5-5F34A1DABEDB}" dt="2026-07-26T17:36:29.015" v="381" actId="478"/>
-          <ac:spMkLst>
-            <pc:docMk/>
-            <pc:sldMk cId="0" sldId="271"/>
-            <ac:spMk id="20" creationId="{00000000-0000-0000-0000-000000000000}"/>
-          </ac:spMkLst>
-        </pc:spChg>
-        <pc:spChg chg="del">
-          <ac:chgData name="231662_Mamoona ." userId="b7081f7e7da24230" providerId="LiveId" clId="{91F99260-498A-4FEC-A0A5-5F34A1DABEDB}" dt="2026-07-26T17:36:29.015" v="381" actId="478"/>
-          <ac:spMkLst>
-            <pc:docMk/>
-            <pc:sldMk cId="0" sldId="271"/>
-            <ac:spMk id="21" creationId="{00000000-0000-0000-0000-000000000000}"/>
-          </ac:spMkLst>
-        </pc:spChg>
-        <pc:spChg chg="del">
-          <ac:chgData name="231662_Mamoona ." userId="b7081f7e7da24230" providerId="LiveId" clId="{91F99260-498A-4FEC-A0A5-5F34A1DABEDB}" dt="2026-07-26T17:36:29.015" v="381" actId="478"/>
-          <ac:spMkLst>
-            <pc:docMk/>
-            <pc:sldMk cId="0" sldId="271"/>
-            <ac:spMk id="22" creationId="{00000000-0000-0000-0000-000000000000}"/>
-          </ac:spMkLst>
-        </pc:spChg>
-        <pc:spChg chg="del">
-          <ac:chgData name="231662_Mamoona ." userId="b7081f7e7da24230" providerId="LiveId" clId="{91F99260-498A-4FEC-A0A5-5F34A1DABEDB}" dt="2026-07-26T17:36:42.072" v="387" actId="478"/>
-          <ac:spMkLst>
-            <pc:docMk/>
-            <pc:sldMk cId="0" sldId="271"/>
-            <ac:spMk id="26" creationId="{00000000-0000-0000-0000-000000000000}"/>
-          </ac:spMkLst>
-        </pc:spChg>
-        <pc:spChg chg="del">
-          <ac:chgData name="231662_Mamoona ." userId="b7081f7e7da24230" providerId="LiveId" clId="{91F99260-498A-4FEC-A0A5-5F34A1DABEDB}" dt="2026-07-26T17:36:32.088" v="382" actId="478"/>
-          <ac:spMkLst>
-            <pc:docMk/>
-            <pc:sldMk cId="0" sldId="271"/>
-            <ac:spMk id="27" creationId="{00000000-0000-0000-0000-000000000000}"/>
-          </ac:spMkLst>
-        </pc:spChg>
-        <pc:spChg chg="del">
-          <ac:chgData name="231662_Mamoona ." userId="b7081f7e7da24230" providerId="LiveId" clId="{91F99260-498A-4FEC-A0A5-5F34A1DABEDB}" dt="2026-07-26T17:36:32.088" v="382" actId="478"/>
-          <ac:spMkLst>
-            <pc:docMk/>
-            <pc:sldMk cId="0" sldId="271"/>
-            <ac:spMk id="28" creationId="{00000000-0000-0000-0000-000000000000}"/>
-          </ac:spMkLst>
-        </pc:spChg>
-        <pc:spChg chg="del">
-          <ac:chgData name="231662_Mamoona ." userId="b7081f7e7da24230" providerId="LiveId" clId="{91F99260-498A-4FEC-A0A5-5F34A1DABEDB}" dt="2026-07-26T17:36:32.088" v="382" actId="478"/>
-          <ac:spMkLst>
-            <pc:docMk/>
-            <pc:sldMk cId="0" sldId="271"/>
-            <ac:spMk id="29" creationId="{00000000-0000-0000-0000-000000000000}"/>
-          </ac:spMkLst>
-        </pc:spChg>
-        <pc:spChg chg="del">
-          <ac:chgData name="231662_Mamoona ." userId="b7081f7e7da24230" providerId="LiveId" clId="{91F99260-498A-4FEC-A0A5-5F34A1DABEDB}" dt="2026-07-26T17:36:32.088" v="382" actId="478"/>
-          <ac:spMkLst>
-            <pc:docMk/>
-            <pc:sldMk cId="0" sldId="271"/>
-            <ac:spMk id="30" creationId="{00000000-0000-0000-0000-000000000000}"/>
-          </ac:spMkLst>
-        </pc:spChg>
-        <pc:spChg chg="del">
-          <ac:chgData name="231662_Mamoona ." userId="b7081f7e7da24230" providerId="LiveId" clId="{91F99260-498A-4FEC-A0A5-5F34A1DABEDB}" dt="2026-07-26T17:36:32.088" v="382" actId="478"/>
-          <ac:spMkLst>
-            <pc:docMk/>
-            <pc:sldMk cId="0" sldId="271"/>
-            <ac:spMk id="31" creationId="{00000000-0000-0000-0000-000000000000}"/>
-          </ac:spMkLst>
-        </pc:spChg>
-        <pc:spChg chg="del">
-          <ac:chgData name="231662_Mamoona ." userId="b7081f7e7da24230" providerId="LiveId" clId="{91F99260-498A-4FEC-A0A5-5F34A1DABEDB}" dt="2026-07-26T17:36:32.088" v="382" actId="478"/>
-          <ac:spMkLst>
-            <pc:docMk/>
-            <pc:sldMk cId="0" sldId="271"/>
-            <ac:spMk id="32" creationId="{00000000-0000-0000-0000-000000000000}"/>
-          </ac:spMkLst>
-        </pc:spChg>
-        <pc:graphicFrameChg chg="add del mod">
-          <ac:chgData name="231662_Mamoona ." userId="b7081f7e7da24230" providerId="LiveId" clId="{91F99260-498A-4FEC-A0A5-5F34A1DABEDB}" dt="2026-07-26T17:36:32.088" v="382" actId="478"/>
-          <ac:graphicFrameMkLst>
-            <pc:docMk/>
-            <pc:sldMk cId="0" sldId="271"/>
-            <ac:graphicFrameMk id="35" creationId="{9F0BB7EB-CB53-E12D-7B97-5DFA3977EEC7}"/>
-          </ac:graphicFrameMkLst>
-        </pc:graphicFrameChg>
         <pc:graphicFrameChg chg="add mod modGraphic">
           <ac:chgData name="231662_Mamoona ." userId="b7081f7e7da24230" providerId="LiveId" clId="{91F99260-498A-4FEC-A0A5-5F34A1DABEDB}" dt="2026-07-26T17:38:35.554" v="433" actId="255"/>
           <ac:graphicFrameMkLst>
@@ -1040,144 +544,12 @@
           </ac:spMkLst>
         </pc:spChg>
       </pc:sldChg>
-      <pc:sldChg chg="del">
-        <pc:chgData name="231662_Mamoona ." userId="b7081f7e7da24230" providerId="LiveId" clId="{91F99260-498A-4FEC-A0A5-5F34A1DABEDB}" dt="2026-07-26T17:18:01.955" v="219" actId="47"/>
-        <pc:sldMkLst>
-          <pc:docMk/>
-          <pc:sldMk cId="0" sldId="275"/>
-        </pc:sldMkLst>
-      </pc:sldChg>
-      <pc:sldChg chg="del">
-        <pc:chgData name="231662_Mamoona ." userId="b7081f7e7da24230" providerId="LiveId" clId="{91F99260-498A-4FEC-A0A5-5F34A1DABEDB}" dt="2026-07-26T17:18:07.283" v="220" actId="47"/>
-        <pc:sldMkLst>
-          <pc:docMk/>
-          <pc:sldMk cId="0" sldId="276"/>
-        </pc:sldMkLst>
-      </pc:sldChg>
-      <pc:sldChg chg="del">
-        <pc:chgData name="231662_Mamoona ." userId="b7081f7e7da24230" providerId="LiveId" clId="{91F99260-498A-4FEC-A0A5-5F34A1DABEDB}" dt="2026-07-26T17:18:15.123" v="221" actId="47"/>
-        <pc:sldMkLst>
-          <pc:docMk/>
-          <pc:sldMk cId="0" sldId="280"/>
-        </pc:sldMkLst>
-      </pc:sldChg>
-      <pc:sldChg chg="addSp modSp new del mod">
-        <pc:chgData name="231662_Mamoona ." userId="b7081f7e7da24230" providerId="LiveId" clId="{91F99260-498A-4FEC-A0A5-5F34A1DABEDB}" dt="2026-07-26T17:23:27.727" v="294" actId="47"/>
-        <pc:sldMkLst>
-          <pc:docMk/>
-          <pc:sldMk cId="3169902040" sldId="286"/>
-        </pc:sldMkLst>
-        <pc:graphicFrameChg chg="add modGraphic">
-          <ac:chgData name="231662_Mamoona ." userId="b7081f7e7da24230" providerId="LiveId" clId="{91F99260-498A-4FEC-A0A5-5F34A1DABEDB}" dt="2026-07-26T17:23:23.394" v="292" actId="21"/>
-          <ac:graphicFrameMkLst>
-            <pc:docMk/>
-            <pc:sldMk cId="3169902040" sldId="286"/>
-            <ac:graphicFrameMk id="3" creationId="{FD336F4C-0E94-7C08-9C57-40BBC2E38DD2}"/>
-          </ac:graphicFrameMkLst>
-        </pc:graphicFrameChg>
-      </pc:sldChg>
       <pc:sldChg chg="addSp delSp modSp add mod">
         <pc:chgData name="231662_Mamoona ." userId="b7081f7e7da24230" providerId="LiveId" clId="{91F99260-498A-4FEC-A0A5-5F34A1DABEDB}" dt="2026-07-26T17:40:04.075" v="441" actId="207"/>
         <pc:sldMkLst>
           <pc:docMk/>
           <pc:sldMk cId="212201433" sldId="287"/>
         </pc:sldMkLst>
-        <pc:spChg chg="del">
-          <ac:chgData name="231662_Mamoona ." userId="b7081f7e7da24230" providerId="LiveId" clId="{91F99260-498A-4FEC-A0A5-5F34A1DABEDB}" dt="2026-07-26T17:23:13.670" v="291" actId="478"/>
-          <ac:spMkLst>
-            <pc:docMk/>
-            <pc:sldMk cId="212201433" sldId="287"/>
-            <ac:spMk id="6" creationId="{FE2C3041-3336-5B84-49AD-9D20E1FDAFB0}"/>
-          </ac:spMkLst>
-        </pc:spChg>
-        <pc:spChg chg="del">
-          <ac:chgData name="231662_Mamoona ." userId="b7081f7e7da24230" providerId="LiveId" clId="{91F99260-498A-4FEC-A0A5-5F34A1DABEDB}" dt="2026-07-26T17:23:13.670" v="291" actId="478"/>
-          <ac:spMkLst>
-            <pc:docMk/>
-            <pc:sldMk cId="212201433" sldId="287"/>
-            <ac:spMk id="8" creationId="{7CC0F984-D0D8-FD34-8A19-F2336D0F45DD}"/>
-          </ac:spMkLst>
-        </pc:spChg>
-        <pc:spChg chg="del">
-          <ac:chgData name="231662_Mamoona ." userId="b7081f7e7da24230" providerId="LiveId" clId="{91F99260-498A-4FEC-A0A5-5F34A1DABEDB}" dt="2026-07-26T17:23:13.670" v="291" actId="478"/>
-          <ac:spMkLst>
-            <pc:docMk/>
-            <pc:sldMk cId="212201433" sldId="287"/>
-            <ac:spMk id="15" creationId="{47238635-1379-68D5-38BC-055590BA83F3}"/>
-          </ac:spMkLst>
-        </pc:spChg>
-        <pc:spChg chg="del">
-          <ac:chgData name="231662_Mamoona ." userId="b7081f7e7da24230" providerId="LiveId" clId="{91F99260-498A-4FEC-A0A5-5F34A1DABEDB}" dt="2026-07-26T17:23:13.670" v="291" actId="478"/>
-          <ac:spMkLst>
-            <pc:docMk/>
-            <pc:sldMk cId="212201433" sldId="287"/>
-            <ac:spMk id="17" creationId="{73D36603-A3AF-60BA-FC13-8B7EC48D90F9}"/>
-          </ac:spMkLst>
-        </pc:spChg>
-        <pc:spChg chg="del">
-          <ac:chgData name="231662_Mamoona ." userId="b7081f7e7da24230" providerId="LiveId" clId="{91F99260-498A-4FEC-A0A5-5F34A1DABEDB}" dt="2026-07-26T17:23:13.670" v="291" actId="478"/>
-          <ac:spMkLst>
-            <pc:docMk/>
-            <pc:sldMk cId="212201433" sldId="287"/>
-            <ac:spMk id="40" creationId="{CBB6502E-D158-F914-4468-16DD1D2A1E9A}"/>
-          </ac:spMkLst>
-        </pc:spChg>
-        <pc:spChg chg="del">
-          <ac:chgData name="231662_Mamoona ." userId="b7081f7e7da24230" providerId="LiveId" clId="{91F99260-498A-4FEC-A0A5-5F34A1DABEDB}" dt="2026-07-26T17:23:13.670" v="291" actId="478"/>
-          <ac:spMkLst>
-            <pc:docMk/>
-            <pc:sldMk cId="212201433" sldId="287"/>
-            <ac:spMk id="41" creationId="{DFD75319-1E2E-1B35-52C4-404D7E285308}"/>
-          </ac:spMkLst>
-        </pc:spChg>
-        <pc:spChg chg="del">
-          <ac:chgData name="231662_Mamoona ." userId="b7081f7e7da24230" providerId="LiveId" clId="{91F99260-498A-4FEC-A0A5-5F34A1DABEDB}" dt="2026-07-26T17:23:13.670" v="291" actId="478"/>
-          <ac:spMkLst>
-            <pc:docMk/>
-            <pc:sldMk cId="212201433" sldId="287"/>
-            <ac:spMk id="51" creationId="{C198ECCE-80B8-2AF0-9119-D195AAA4202D}"/>
-          </ac:spMkLst>
-        </pc:spChg>
-        <pc:spChg chg="del">
-          <ac:chgData name="231662_Mamoona ." userId="b7081f7e7da24230" providerId="LiveId" clId="{91F99260-498A-4FEC-A0A5-5F34A1DABEDB}" dt="2026-07-26T17:23:13.670" v="291" actId="478"/>
-          <ac:spMkLst>
-            <pc:docMk/>
-            <pc:sldMk cId="212201433" sldId="287"/>
-            <ac:spMk id="58" creationId="{5EDBEA8E-4E91-BDF6-B985-9465058020AA}"/>
-          </ac:spMkLst>
-        </pc:spChg>
-        <pc:spChg chg="del">
-          <ac:chgData name="231662_Mamoona ." userId="b7081f7e7da24230" providerId="LiveId" clId="{91F99260-498A-4FEC-A0A5-5F34A1DABEDB}" dt="2026-07-26T17:23:13.670" v="291" actId="478"/>
-          <ac:spMkLst>
-            <pc:docMk/>
-            <pc:sldMk cId="212201433" sldId="287"/>
-            <ac:spMk id="69" creationId="{012A8A52-8C43-2023-3E5C-A4A754DDF1DD}"/>
-          </ac:spMkLst>
-        </pc:spChg>
-        <pc:spChg chg="del">
-          <ac:chgData name="231662_Mamoona ." userId="b7081f7e7da24230" providerId="LiveId" clId="{91F99260-498A-4FEC-A0A5-5F34A1DABEDB}" dt="2026-07-26T17:23:13.670" v="291" actId="478"/>
-          <ac:spMkLst>
-            <pc:docMk/>
-            <pc:sldMk cId="212201433" sldId="287"/>
-            <ac:spMk id="76" creationId="{B395F701-657E-17AF-2299-5053CECEC6FB}"/>
-          </ac:spMkLst>
-        </pc:spChg>
-        <pc:spChg chg="mod">
-          <ac:chgData name="231662_Mamoona ." userId="b7081f7e7da24230" providerId="LiveId" clId="{91F99260-498A-4FEC-A0A5-5F34A1DABEDB}" dt="2026-07-26T17:23:09.366" v="290" actId="1076"/>
-          <ac:spMkLst>
-            <pc:docMk/>
-            <pc:sldMk cId="212201433" sldId="287"/>
-            <ac:spMk id="101" creationId="{E95D31C3-CCC6-F539-6169-974D7A8D8308}"/>
-          </ac:spMkLst>
-        </pc:spChg>
-        <pc:graphicFrameChg chg="add del mod modGraphic">
-          <ac:chgData name="231662_Mamoona ." userId="b7081f7e7da24230" providerId="LiveId" clId="{91F99260-498A-4FEC-A0A5-5F34A1DABEDB}" dt="2026-07-26T17:25:27.767" v="309" actId="478"/>
-          <ac:graphicFrameMkLst>
-            <pc:docMk/>
-            <pc:sldMk cId="212201433" sldId="287"/>
-            <ac:graphicFrameMk id="105" creationId="{5002F4B2-83BC-412A-3AB3-38EFF0C696CC}"/>
-          </ac:graphicFrameMkLst>
-        </pc:graphicFrameChg>
         <pc:graphicFrameChg chg="add mod modGraphic">
           <ac:chgData name="231662_Mamoona ." userId="b7081f7e7da24230" providerId="LiveId" clId="{91F99260-498A-4FEC-A0A5-5F34A1DABEDB}" dt="2026-07-26T17:40:04.075" v="441" actId="207"/>
           <ac:graphicFrameMkLst>
@@ -4406,29 +3778,6 @@
           </a:p>
         </p:txBody>
       </p:sp>
-      <p:pic>
-        <p:nvPicPr>
-          <p:cNvPr id="19" name="Image 0" descr="C:\Users\mamoo_degcn9g\AppData\Local\Temp\claude\C--Users-mamoo-degcn9g-OneDrive-Documents-FYP-conceptintel\f051ca33-27d2-49d4-b922-df84a1f16853\scratchpad\pitch/screens/landing.png"/>
-          <p:cNvPicPr>
-            <a:picLocks noChangeAspect="1"/>
-          </p:cNvPicPr>
-          <p:nvPr/>
-        </p:nvPicPr>
-        <p:blipFill>
-          <a:blip r:embed="rId3"/>
-          <a:srcRect/>
-          <a:stretch/>
-        </p:blipFill>
-        <p:spPr>
-          <a:xfrm>
-            <a:off x="5211000" y="2411738"/>
-            <a:ext cx="6688104" cy="3024923"/>
-          </a:xfrm>
-          <a:prstGeom prst="rect">
-            <a:avLst/>
-          </a:prstGeom>
-        </p:spPr>
-      </p:pic>
       <p:sp>
         <p:nvSpPr>
           <p:cNvPr id="20" name="Text 17"/>

</xml_diff>